<commit_message>
feat: align repeat surgery logic in trend analysis with morbidity analysis clean
- Standardize repeat surgery categories to exactly match morbidity analysis clean:
  REBUBBLING, WOUND_RESUTURING, KP, and Others
- Classify REBUBBLING, WOUND_RESUTURING, and KP as real repeat surgeries; Others as minor/supportive procedures
- Update Table 4 (Resurgery Breakdown), Table 5, Table 6, and PPTX charts to show clean breakdown
- Synchronize app.py and multi_month_trend_analysis.ipynb
- Regenerate sample Multi_Month_Trend_Report.pptx
</commit_message>
<xml_diff>
--- a/Multi_Month_Trend_Report.pptx
+++ b/Multi_Month_Trend_Report.pptx
@@ -3230,7 +3230,7 @@
               </a:defRPr>
             </a:pPr>
             <a:r>
-              <a:t>Across March 2026, April 2026, May</a:t>
+              <a:t>Across March 2026, April 2026, May 2026</a:t>
             </a:r>
           </a:p>
         </p:txBody>
@@ -3362,7 +3362,7 @@
               </a:defRPr>
             </a:pPr>
             <a:r>
-              <a:t>1M GRAFT RESURGERY RATE</a:t>
+              <a:t>1M REPEAT SURGERY RATE</a:t>
             </a:r>
           </a:p>
           <a:p>
@@ -3374,7 +3374,7 @@
               </a:defRPr>
             </a:pPr>
             <a:r>
-              <a:t>34 (3.81%)</a:t>
+              <a:t>27 (3.02%)</a:t>
             </a:r>
           </a:p>
           <a:p>
@@ -3386,7 +3386,7 @@
               </a:defRPr>
             </a:pPr>
             <a:r>
-              <a:t>Rebubbling, Resuturing, KP</a:t>
+              <a:t>REBUBBLING, RESUTURING, KP</a:t>
             </a:r>
           </a:p>
         </p:txBody>
@@ -3464,7 +3464,7 @@
               </a:defRPr>
             </a:pPr>
             <a:r>
-              <a:t>Includes IOAB Injections &amp; EUA</a:t>
+              <a:t>Includes Minor (Others)</a:t>
             </a:r>
           </a:p>
         </p:txBody>
@@ -3876,7 +3876,7 @@
               </a:defRPr>
             </a:pPr>
             <a:r>
-              <a:t>Resurgery &amp; Re-intervention Clinical Categorization Breakdown (11–45 Days)</a:t>
+              <a:t>Repeat Surgery Breakdown (11–45 Days Post-Surgery)</a:t>
             </a:r>
           </a:p>
           <a:p>
@@ -3888,7 +3888,7 @@
               </a:defRPr>
             </a:pPr>
             <a:r>
-              <a:t>Criteria: True Graft Resurgeries vs. Supportive / In-Clinic Interventions (IOAB Injections, EUA, Tarsorrhaphy)</a:t>
+              <a:t>Criteria: Real Repeat Surgeries (REBUBBLING, WOUND_RESUTURING, KP) vs. Others (Minor Procedures)</a:t>
             </a:r>
           </a:p>
         </p:txBody>

</xml_diff>

<commit_message>
feat: add visual impairment confusion matrix dashboard & update trend pptx to show resurgery proportions without heterogeneous reinterventions
</commit_message>
<xml_diff>
--- a/Multi_Month_Trend_Report.pptx
+++ b/Multi_Month_Trend_Report.pptx
@@ -3362,7 +3362,7 @@
               </a:defRPr>
             </a:pPr>
             <a:r>
-              <a:t>1M REPEAT SURGERY RATE</a:t>
+              <a:t>1M IDENTIFIED RESURGERIES</a:t>
             </a:r>
           </a:p>
           <a:p>
@@ -3386,7 +3386,7 @@
               </a:defRPr>
             </a:pPr>
             <a:r>
-              <a:t>REBUBBLING, RESUTURING, KP</a:t>
+              <a:t>Rebubbling, Resuturing, KP</a:t>
             </a:r>
           </a:p>
         </p:txBody>
@@ -3440,7 +3440,7 @@
               </a:defRPr>
             </a:pPr>
             <a:r>
-              <a:t>ALL RE-INTERVENTIONS</a:t>
+              <a:t>1M REPEAT KERATOPLASTY (KP)</a:t>
             </a:r>
           </a:p>
           <a:p>
@@ -3452,7 +3452,7 @@
               </a:defRPr>
             </a:pPr>
             <a:r>
-              <a:t>161 (18.03%)</a:t>
+              <a:t>12 (1.34%)</a:t>
             </a:r>
           </a:p>
           <a:p>
@@ -3464,7 +3464,7 @@
               </a:defRPr>
             </a:pPr>
             <a:r>
-              <a:t>Includes Minor (Others)</a:t>
+              <a:t>Specific Repeat KP / Graft Replacement</a:t>
             </a:r>
           </a:p>
         </p:txBody>
@@ -3782,7 +3782,7 @@
               </a:defRPr>
             </a:pPr>
             <a:r>
-              <a:t>Criteria: Graft-Specific Resurgeries: Rebubbling / Descematopexy, Wound Resuturing, and Repeat Keratoplasty (KP)</a:t>
+              <a:t>Criteria: Re-surgeries shown as a proportion (%) of Total Surgeries for each Campus (Rebubbling, Resuturing, KP)</a:t>
             </a:r>
           </a:p>
         </p:txBody>
@@ -3876,7 +3876,7 @@
               </a:defRPr>
             </a:pPr>
             <a:r>
-              <a:t>Repeat Surgery Breakdown (11–45 Days Post-Surgery)</a:t>
+              <a:t>Repeat Surgery Rates by Specific Identified Category (11–45 Days Post-Surgery)</a:t>
             </a:r>
           </a:p>
           <a:p>
@@ -3888,7 +3888,7 @@
               </a:defRPr>
             </a:pPr>
             <a:r>
-              <a:t>Criteria: Real Repeat Surgeries (REBUBBLING, WOUND_RESUTURING, KP) vs. Others (Minor Procedures)</a:t>
+              <a:t>Criteria: Proportions (%) of Total Primary Surgeries: Rebubbling, Wound Resuturing, and Repeat Keratoplasty (KP)</a:t>
             </a:r>
           </a:p>
         </p:txBody>
@@ -3994,7 +3994,7 @@
               </a:defRPr>
             </a:pPr>
             <a:r>
-              <a:t>Criteria: Summary Scorecard &amp; Surgical Procedure Risk Distribution</a:t>
+              <a:t>Criteria: Re-surgeries shown as a proportion (%) of Total Surgeries for each Surgery Type</a:t>
             </a:r>
           </a:p>
         </p:txBody>

</xml_diff>